<commit_message>
Add PEEP/FiO2 pairing figure (M9.3)
Completes the named visuals list bar the circuit diagram and panel close-ups.
Renders only the ARDSNet lower-PEEP anchor points already taught in the course
(0.3->5, 0.5->8-10, 0.7->10-14, 0.9->14-18, 1.0->18-24) as ascending bars, with
the teaching point that PEEP and FiO2 rise together and the caveat that these
are anchor points only — carry the full card and follow service protocol. No new
clinical numbers introduced.

Shown in the app (module 9 lesson 3) and in the decks; 10/10 decks validate.

Co-Authored-By: Claude Opus 4.8 <noreply@anthropic.com>
Claude-Session: https://claude.ai/code/session_018TgmvsT9g1Ho59Cx7HDF4r
</commit_message>
<xml_diff>
--- a/vta/slides/Module_9_Special_Populations.pptx
+++ b/vta/slides/Module_9_Special_Populations.pptx
@@ -4227,151 +4227,30 @@
           </a:p>
         </p:txBody>
       </p:sp>
-      <p:sp>
-        <p:nvSpPr>
-          <p:cNvPr id="6" name="Shape 4"/>
-          <p:cNvSpPr/>
-          <p:nvPr/>
-        </p:nvSpPr>
-        <p:spPr>
-          <a:xfrm>
-            <a:off x="7315200" y="2148840"/>
-            <a:ext cx="4325112" cy="3840480"/>
-          </a:xfrm>
-          <a:prstGeom prst="roundRect">
-            <a:avLst>
-              <a:gd name="adj" fmla="val 2381"/>
-            </a:avLst>
-          </a:prstGeom>
-          <a:solidFill>
-            <a:srgbClr val="E7F0FD"/>
-          </a:solidFill>
-          <a:ln/>
-        </p:spPr>
-      </p:sp>
-      <p:sp>
-        <p:nvSpPr>
-          <p:cNvPr id="7" name="Text 5"/>
-          <p:cNvSpPr/>
-          <p:nvPr/>
-        </p:nvSpPr>
-        <p:spPr>
-          <a:xfrm>
-            <a:off x="7589520" y="2377440"/>
-            <a:ext cx="3776472" cy="320040"/>
+      <p:pic>
+        <p:nvPicPr>
+          <p:cNvPr id="6" name="Image 0" descr="/tmp/claude-0/-home-user-amr-kc-protocols/883711fe-5eaa-500f-ae13-4d63d2ddcc7e/scratchpad/pngs/peep_fio2.png">    </p:cNvPr>
+          <p:cNvPicPr>
+            <a:picLocks noChangeAspect="1"/>
+          </p:cNvPicPr>
+          <p:nvPr/>
+        </p:nvPicPr>
+        <p:blipFill>
+          <a:blip r:embed="rId1"/>
+          <a:stretch>
+            <a:fillRect/>
+          </a:stretch>
+        </p:blipFill>
+        <p:spPr>
+          <a:xfrm>
+            <a:off x="7040880" y="2746393"/>
+            <a:ext cx="4709160" cy="2096734"/>
           </a:xfrm>
           <a:prstGeom prst="rect">
             <a:avLst/>
           </a:prstGeom>
-          <a:noFill/>
-          <a:ln/>
-        </p:spPr>
-        <p:txBody>
-          <a:bodyPr wrap="square" rtlCol="0" anchor="ctr"/>
-          <a:lstStyle/>
-          <a:p>
-            <a:pPr indent="0" marL="0">
-              <a:buNone/>
-            </a:pPr>
-            <a:r>
-              <a:rPr lang="en-US" sz="1200" b="1" spc="200" kern="0" dirty="0">
-                <a:solidFill>
-                  <a:srgbClr val="1B63C4"/>
-                </a:solidFill>
-                <a:latin typeface="Calibri" pitchFamily="34" charset="0"/>
-                <a:ea typeface="Calibri" pitchFamily="34" charset="-122"/>
-                <a:cs typeface="Calibri" pitchFamily="34" charset="-120"/>
-              </a:rPr>
-              <a:t>EVIDENCE</a:t>
-            </a:r>
-            <a:endParaRPr lang="en-US" sz="1200" dirty="0"/>
-          </a:p>
-        </p:txBody>
-      </p:sp>
-      <p:sp>
-        <p:nvSpPr>
-          <p:cNvPr id="8" name="Text 6"/>
-          <p:cNvSpPr/>
-          <p:nvPr/>
-        </p:nvSpPr>
-        <p:spPr>
-          <a:xfrm>
-            <a:off x="7589520" y="2715768"/>
-            <a:ext cx="3776472" cy="640080"/>
-          </a:xfrm>
-          <a:prstGeom prst="rect">
-            <a:avLst/>
-          </a:prstGeom>
-          <a:noFill/>
-          <a:ln/>
-        </p:spPr>
-        <p:txBody>
-          <a:bodyPr wrap="square" rtlCol="0" anchor="t"/>
-          <a:lstStyle/>
-          <a:p>
-            <a:pPr indent="0" marL="0">
-              <a:lnSpc>
-                <a:spcPct val="95000"/>
-              </a:lnSpc>
-              <a:buNone/>
-            </a:pPr>
-            <a:r>
-              <a:rPr lang="en-US" sz="1700" b="1" dirty="0">
-                <a:solidFill>
-                  <a:srgbClr val="173A68"/>
-                </a:solidFill>
-                <a:latin typeface="Cambria" pitchFamily="34" charset="0"/>
-                <a:ea typeface="Cambria" pitchFamily="34" charset="-122"/>
-                <a:cs typeface="Cambria" pitchFamily="34" charset="-120"/>
-              </a:rPr>
-              <a:t>ARDSNet PEEP/FiO₂ Lower-PEEP Table</a:t>
-            </a:r>
-            <a:endParaRPr lang="en-US" sz="1700" dirty="0"/>
-          </a:p>
-        </p:txBody>
-      </p:sp>
-      <p:sp>
-        <p:nvSpPr>
-          <p:cNvPr id="9" name="Text 7"/>
-          <p:cNvSpPr/>
-          <p:nvPr/>
-        </p:nvSpPr>
-        <p:spPr>
-          <a:xfrm>
-            <a:off x="7589520" y="3474720"/>
-            <a:ext cx="3776472" cy="2286000"/>
-          </a:xfrm>
-          <a:prstGeom prst="rect">
-            <a:avLst/>
-          </a:prstGeom>
-          <a:noFill/>
-          <a:ln/>
-        </p:spPr>
-        <p:txBody>
-          <a:bodyPr wrap="square" rtlCol="0" anchor="t"/>
-          <a:lstStyle/>
-          <a:p>
-            <a:pPr indent="0" marL="0">
-              <a:lnSpc>
-                <a:spcPct val="103000"/>
-              </a:lnSpc>
-              <a:buNone/>
-            </a:pPr>
-            <a:r>
-              <a:rPr lang="en-US" sz="1350" dirty="0">
-                <a:solidFill>
-                  <a:srgbClr val="1B2433"/>
-                </a:solidFill>
-                <a:latin typeface="Calibri" pitchFamily="34" charset="0"/>
-                <a:ea typeface="Calibri" pitchFamily="34" charset="-122"/>
-                <a:cs typeface="Calibri" pitchFamily="34" charset="-120"/>
-              </a:rPr>
-              <a:t>FiO₂ 0.3 → PEEP 5. FiO₂ 0.5 → PEEP 8–10. FiO₂ 0.7 → PEEP 10–14. FiO₂ 1.0 → PEEP 18–24. Carry the card.</a:t>
-            </a:r>
-            <a:endParaRPr lang="en-US" sz="1350" dirty="0"/>
-          </a:p>
-        </p:txBody>
-      </p:sp>
+        </p:spPr>
+      </p:pic>
     </p:spTree>
   </p:cSld>
   <p:clrMapOvr>

</xml_diff>